<commit_message>
Minor adjustments in plot of evolution path
</commit_message>
<xml_diff>
--- a/examples/data_for_paper_tvha/variational_adiabatic_evolution_path.pptx
+++ b/examples/data_for_paper_tvha/variational_adiabatic_evolution_path.pptx
@@ -104,6 +104,11 @@
       </a:defRPr>
     </a:lvl9pPr>
   </p:defaultTextStyle>
+  <p:extLst>
+    <p:ext uri="{EFAFB233-063F-42B5-8137-9DF3F51BA10A}">
+      <p15:sldGuideLst xmlns:p15="http://schemas.microsoft.com/office/powerpoint/2012/main"/>
+    </p:ext>
+  </p:extLst>
 </p:presentation>
 </file>
 
@@ -3335,10 +3340,10 @@
         </p:nvGrpSpPr>
         <p:grpSpPr>
           <a:xfrm>
-            <a:off x="599783" y="791837"/>
-            <a:ext cx="10030468" cy="4686624"/>
-            <a:chOff x="599783" y="791837"/>
-            <a:chExt cx="10030468" cy="4686624"/>
+            <a:off x="538926" y="791837"/>
+            <a:ext cx="10603836" cy="4443781"/>
+            <a:chOff x="538926" y="791837"/>
+            <a:chExt cx="10603836" cy="4443781"/>
           </a:xfrm>
         </p:grpSpPr>
         <p:sp>
@@ -3746,8 +3751,8 @@
           </p:nvCxnSpPr>
           <p:spPr>
             <a:xfrm flipV="1">
-              <a:off x="8695267" y="3029403"/>
-              <a:ext cx="1756833" cy="1766456"/>
+              <a:off x="8695267" y="2915619"/>
+              <a:ext cx="1934984" cy="1880240"/>
             </a:xfrm>
             <a:prstGeom prst="straightConnector1">
               <a:avLst/>
@@ -3879,8 +3884,8 @@
           </p:nvSpPr>
           <p:spPr>
             <a:xfrm>
-              <a:off x="599783" y="2346955"/>
-              <a:ext cx="625492" cy="523220"/>
+              <a:off x="538926" y="2346955"/>
+              <a:ext cx="686349" cy="523220"/>
             </a:xfrm>
             <a:prstGeom prst="rect">
               <a:avLst/>
@@ -3899,6 +3904,8 @@
                   <a:solidFill>
                     <a:srgbClr val="CCDEE5"/>
                   </a:solidFill>
+                  <a:latin typeface="Arial" panose="020B0604020202020204" pitchFamily="34" charset="0"/>
+                  <a:cs typeface="Arial" panose="020B0604020202020204" pitchFamily="34" charset="0"/>
                 </a:rPr>
                 <a:t>HF</a:t>
               </a:r>
@@ -3975,8 +3982,8 @@
           </p:nvSpPr>
           <p:spPr>
             <a:xfrm>
-              <a:off x="9918325" y="1512292"/>
-              <a:ext cx="711926" cy="523220"/>
+              <a:off x="9918324" y="1512292"/>
+              <a:ext cx="779211" cy="523220"/>
             </a:xfrm>
             <a:prstGeom prst="rect">
               <a:avLst/>
@@ -3995,6 +4002,8 @@
                   <a:solidFill>
                     <a:srgbClr val="FDB913"/>
                   </a:solidFill>
+                  <a:latin typeface="Arial" panose="020B0604020202020204" pitchFamily="34" charset="0"/>
+                  <a:cs typeface="Arial" panose="020B0604020202020204" pitchFamily="34" charset="0"/>
                 </a:rPr>
                 <a:t>FCI</a:t>
               </a:r>
@@ -4239,8 +4248,8 @@
             <p:nvPr/>
           </p:nvSpPr>
           <p:spPr>
-            <a:xfrm rot="18883393">
-              <a:off x="8365084" y="3914731"/>
+            <a:xfrm rot="18970133">
+              <a:off x="8415412" y="3843429"/>
               <a:ext cx="2727350" cy="400110"/>
             </a:xfrm>
             <a:prstGeom prst="rect">
@@ -4260,6 +4269,8 @@
                   <a:solidFill>
                     <a:srgbClr val="F58220"/>
                   </a:solidFill>
+                  <a:latin typeface="Arial" panose="020B0604020202020204" pitchFamily="34" charset="0"/>
+                  <a:cs typeface="Arial" panose="020B0604020202020204" pitchFamily="34" charset="0"/>
                 </a:rPr>
                 <a:t>discrete</a:t>
               </a:r>
@@ -4268,6 +4279,8 @@
                   <a:solidFill>
                     <a:srgbClr val="F58220"/>
                   </a:solidFill>
+                  <a:latin typeface="Arial" panose="020B0604020202020204" pitchFamily="34" charset="0"/>
+                  <a:cs typeface="Arial" panose="020B0604020202020204" pitchFamily="34" charset="0"/>
                 </a:rPr>
                 <a:t> </a:t>
               </a:r>
@@ -4276,6 +4289,8 @@
                   <a:solidFill>
                     <a:srgbClr val="F58220"/>
                   </a:solidFill>
+                  <a:latin typeface="Arial" panose="020B0604020202020204" pitchFamily="34" charset="0"/>
+                  <a:cs typeface="Arial" panose="020B0604020202020204" pitchFamily="34" charset="0"/>
                 </a:rPr>
                 <a:t>adiabatic</a:t>
               </a:r>
@@ -4284,6 +4299,8 @@
                   <a:solidFill>
                     <a:srgbClr val="F58220"/>
                   </a:solidFill>
+                  <a:latin typeface="Arial" panose="020B0604020202020204" pitchFamily="34" charset="0"/>
+                  <a:cs typeface="Arial" panose="020B0604020202020204" pitchFamily="34" charset="0"/>
                 </a:rPr>
                 <a:t> </a:t>
               </a:r>
@@ -4292,6 +4309,8 @@
                   <a:solidFill>
                     <a:srgbClr val="F58220"/>
                   </a:solidFill>
+                  <a:latin typeface="Arial" panose="020B0604020202020204" pitchFamily="34" charset="0"/>
+                  <a:cs typeface="Arial" panose="020B0604020202020204" pitchFamily="34" charset="0"/>
                 </a:rPr>
                 <a:t>path</a:t>
               </a:r>
@@ -4299,6 +4318,8 @@
                 <a:solidFill>
                   <a:srgbClr val="F58220"/>
                 </a:solidFill>
+                <a:latin typeface="Arial" panose="020B0604020202020204" pitchFamily="34" charset="0"/>
+                <a:cs typeface="Arial" panose="020B0604020202020204" pitchFamily="34" charset="0"/>
               </a:endParaRPr>
             </a:p>
           </p:txBody>
@@ -4317,8 +4338,8 @@
           </p:nvSpPr>
           <p:spPr>
             <a:xfrm rot="3791381">
-              <a:off x="6692568" y="1776332"/>
-              <a:ext cx="1902509" cy="400110"/>
+              <a:off x="6559689" y="1729944"/>
+              <a:ext cx="2121382" cy="400110"/>
             </a:xfrm>
             <a:prstGeom prst="rect">
               <a:avLst/>
@@ -4337,6 +4358,8 @@
                   <a:solidFill>
                     <a:srgbClr val="005B7F"/>
                   </a:solidFill>
+                  <a:latin typeface="Arial" panose="020B0604020202020204" pitchFamily="34" charset="0"/>
+                  <a:cs typeface="Arial" panose="020B0604020202020204" pitchFamily="34" charset="0"/>
                 </a:rPr>
                 <a:t>variational</a:t>
               </a:r>
@@ -4345,6 +4368,8 @@
                   <a:solidFill>
                     <a:srgbClr val="005B7F"/>
                   </a:solidFill>
+                  <a:latin typeface="Arial" panose="020B0604020202020204" pitchFamily="34" charset="0"/>
+                  <a:cs typeface="Arial" panose="020B0604020202020204" pitchFamily="34" charset="0"/>
                 </a:rPr>
                 <a:t> </a:t>
               </a:r>
@@ -4353,6 +4378,8 @@
                   <a:solidFill>
                     <a:srgbClr val="005B7F"/>
                   </a:solidFill>
+                  <a:latin typeface="Arial" panose="020B0604020202020204" pitchFamily="34" charset="0"/>
+                  <a:cs typeface="Arial" panose="020B0604020202020204" pitchFamily="34" charset="0"/>
                 </a:rPr>
                 <a:t>path</a:t>
               </a:r>
@@ -4360,6 +4387,8 @@
                 <a:solidFill>
                   <a:srgbClr val="005B7F"/>
                 </a:solidFill>
+                <a:latin typeface="Arial" panose="020B0604020202020204" pitchFamily="34" charset="0"/>
+                <a:cs typeface="Arial" panose="020B0604020202020204" pitchFamily="34" charset="0"/>
               </a:endParaRPr>
             </a:p>
           </p:txBody>
@@ -4394,18 +4423,30 @@
             <a:p>
               <a:pPr algn="ctr"/>
               <a:r>
-                <a:rPr lang="de-DE" sz="2000" dirty="0" err="1"/>
+                <a:rPr lang="de-DE" sz="2000" dirty="0" err="1">
+                  <a:latin typeface="Arial" panose="020B0604020202020204" pitchFamily="34" charset="0"/>
+                  <a:cs typeface="Arial" panose="020B0604020202020204" pitchFamily="34" charset="0"/>
+                </a:rPr>
                 <a:t>adiabatic</a:t>
               </a:r>
               <a:r>
-                <a:rPr lang="de-DE" sz="2000" dirty="0"/>
+                <a:rPr lang="de-DE" sz="2000" dirty="0">
+                  <a:latin typeface="Arial" panose="020B0604020202020204" pitchFamily="34" charset="0"/>
+                  <a:cs typeface="Arial" panose="020B0604020202020204" pitchFamily="34" charset="0"/>
+                </a:rPr>
                 <a:t> </a:t>
               </a:r>
               <a:r>
-                <a:rPr lang="de-DE" sz="2000" dirty="0" err="1"/>
+                <a:rPr lang="de-DE" sz="2000" dirty="0" err="1">
+                  <a:latin typeface="Arial" panose="020B0604020202020204" pitchFamily="34" charset="0"/>
+                  <a:cs typeface="Arial" panose="020B0604020202020204" pitchFamily="34" charset="0"/>
+                </a:rPr>
                 <a:t>path</a:t>
               </a:r>
-              <a:endParaRPr lang="de-DE" sz="2000" dirty="0"/>
+              <a:endParaRPr lang="de-DE" sz="2000" dirty="0">
+                <a:latin typeface="Arial" panose="020B0604020202020204" pitchFamily="34" charset="0"/>
+                <a:cs typeface="Arial" panose="020B0604020202020204" pitchFamily="34" charset="0"/>
+              </a:endParaRPr>
             </a:p>
           </p:txBody>
         </p:sp>

</xml_diff>